<commit_message>
feat: modernize document rag assistant
</commit_message>
<xml_diff>
--- a/tests/sample_docs/sample_zh.pptx
+++ b/tests/sample_docs/sample_zh.pptx
@@ -3128,7 +3128,7 @@
           <a:lstStyle/>
           <a:p>
             <a:r>
-              <a:t>本项目旨在构建一个基于 RAG（检索增强生成）的智能文档问答系统。系统支持 PDF、DOCX、XLSX、PPTX、TXT、Markdown 六种文档格式的解析与索引。</a:t>
+              <a:t>本项目旨在构建一个基于 RAG（检索增强生成）的智能文档问答系统。核心链路支持中文 PDF 与 DOCX 的解析、索引和可追溯问答。</a:t>
             </a:r>
           </a:p>
         </p:txBody>
@@ -3188,7 +3188,7 @@
           <a:lstStyle/>
           <a:p>
             <a:r>
-              <a:t>系统采用四层模块化架构：文档处理层(DocumentProcessor)负责多格式解析与分块；向量存储层(VectorStoreManager)基于 ChromaDB 实现增量索引与 SHA-256 去重；问答引擎层(QAEngine)实现 RAG 链路，集成语义缓存；Agent 层(AgentSession)采用手写 ReAct 循环，兼容 DeepSeek 推理模型。</a:t>
+              <a:t>系统采用分层模块化架构：文档处理层(DocumentProcessor)保留页码与段落来源；向量存储层(VectorStoreManager)为每份文档创建独立索引；问答引擎层(QAEngine)使用同一批检索片段生成回答与引用；Agent 层(AgentSession)采用 Pydantic 结构化意图路由。</a:t>
             </a:r>
           </a:p>
         </p:txBody>
@@ -3248,12 +3248,12 @@
           <a:lstStyle/>
           <a:p>
             <a:r>
-              <a:t>1. 六种文档格式自动解析与清洗</a:t>
-            </a:r>
-          </a:p>
-          <a:p>
-            <a:r>
-              <a:t>2. 基于 RecursiveCharacterTextSplitter 的分块（chunk_size=1000, overlap=200）</a:t>
+              <a:t>1. 中文 PDF/DOCX 自动解析与来源保留</a:t>
+            </a:r>
+          </a:p>
+          <a:p>
+            <a:r>
+              <a:t>2. 规则分块与小型本地语义模型分块</a:t>
             </a:r>
           </a:p>
           <a:p>
@@ -3268,12 +3268,12 @@
           </a:p>
           <a:p>
             <a:r>
-              <a:t>5. 多模型嵌入（DashScope → OpenAI → Ollama 三级回退，自动适配维度）</a:t>
-            </a:r>
-          </a:p>
-          <a:p>
-            <a:r>
-              <a:t>6. 手写 ReAct A</a:t>
+              <a:t>5. Chat 与 Embedding 使用独立、显式的 OpenAI 兼容 API 配置</a:t>
+            </a:r>
+          </a:p>
+          <a:p>
+            <a:r>
+              <a:t>6. 结构化意图 Agent，支持文档问答/摘要/结构分析/信息提取/翻译/报告生成/文档对比</a:t>
             </a:r>
           </a:p>
         </p:txBody>
@@ -3338,22 +3338,12 @@
           </a:p>
           <a:p>
             <a:r>
-              <a:t>- DASHSCOPE_API_KEY → text-embedding-v3</a:t>
-            </a:r>
-          </a:p>
-          <a:p>
-            <a:r>
-              <a:t>- OPENAI_API_KEY → text-embedding-3-small</a:t>
-            </a:r>
-          </a:p>
-          <a:p>
-            <a:r>
-              <a:t>- 均不可用时 → 回退到 Ollama(nomic-embed-text)</a:t>
-            </a:r>
-          </a:p>
-          <a:p>
-            <a:r>
-              <a:t>三种模型的输出维度不同（1536/1536/768），系统自动检测向量库已有维度并匹配。</a:t>
+              <a:t>- EMBEDDING_API_KEY / EMBEDDING_BASE_URL / EMBEDDING_MODEL</a:t>
+            </a:r>
+          </a:p>
+          <a:p>
+            <a:r>
+              <a:t>索引按模型与文档隔离，维度不兼容时保留旧索引并明确报错。</a:t>
             </a:r>
           </a:p>
         </p:txBody>

</xml_diff>